<commit_message>
spike(deck): mockups with Canva-available fonts
Co-Authored-By: Claude Opus 5.5 <noreply@anthropic.com>
Claude-Session: https://claude.ai/code/session_016QENrZoUiH2GSA5C6QaHnv
</commit_message>
<xml_diff>
--- a/deck/mockups/out/mockups.pptx
+++ b/deck/mockups/out/mockups.pptx
@@ -3109,8 +3109,8 @@
         </p:nvSpPr>
         <p:spPr>
           <a:xfrm>
-            <a:off x="7048500" y="0"/>
-            <a:ext cx="5143500" cy="6858000"/>
+            <a:off x="7493000" y="0"/>
+            <a:ext cx="4699000" cy="6858000"/>
           </a:xfrm>
           <a:prstGeom prst="rect">
             <a:avLst/>
@@ -3177,7 +3177,7 @@
                 <a:solidFill>
                   <a:srgbClr val="B9C6DA"/>
                 </a:solidFill>
-                <a:latin typeface="Instrument Sans"/>
+                <a:latin typeface="DM Sans"/>
               </a:rPr>
               <a:t>40 answers, collected on 9 October 2026</a:t>
             </a:r>
@@ -3192,8 +3192,8 @@
         </p:nvSpPr>
         <p:spPr>
           <a:xfrm>
-            <a:off x="762000" y="1905000"/>
-            <a:ext cx="6413500" cy="1514856"/>
+            <a:off x="762000" y="1778000"/>
+            <a:ext cx="6540500" cy="1154176"/>
           </a:xfrm>
           <a:prstGeom prst="rect">
             <a:avLst/>
@@ -3212,11 +3212,11 @@
               </a:lnSpc>
             </a:pPr>
             <a:r>
-              <a:rPr sz="8400" b="0" i="0">
+              <a:rPr sz="6400" b="0" i="0">
                 <a:solidFill>
                   <a:srgbClr val="F6F3EC"/>
                 </a:solidFill>
-                <a:latin typeface="Instrument Serif"/>
+                <a:latin typeface="DM Serif Display"/>
               </a:rPr>
               <a:t>Favoured Banks</a:t>
             </a:r>
@@ -3231,7 +3231,7 @@
         </p:nvSpPr>
         <p:spPr>
           <a:xfrm>
-            <a:off x="787400" y="3483355"/>
+            <a:off x="787400" y="2995676"/>
             <a:ext cx="889000" cy="25400"/>
           </a:xfrm>
           <a:prstGeom prst="rect">
@@ -3275,8 +3275,8 @@
         </p:nvSpPr>
         <p:spPr>
           <a:xfrm>
-            <a:off x="762000" y="3737355"/>
-            <a:ext cx="5715000" cy="1514856"/>
+            <a:off x="762000" y="3249676"/>
+            <a:ext cx="5588000" cy="1406652"/>
           </a:xfrm>
           <a:prstGeom prst="rect">
             <a:avLst/>
@@ -3295,11 +3295,11 @@
               </a:lnSpc>
             </a:pPr>
             <a:r>
-              <a:rPr sz="2800" b="0" i="1">
+              <a:rPr sz="2600" b="0" i="0">
                 <a:solidFill>
                   <a:srgbClr val="B9C6DA"/>
                 </a:solidFill>
-                <a:latin typeface="Instrument Serif"/>
+                <a:latin typeface="DM Sans"/>
               </a:rPr>
               <a:t>Which Indonesian banks ChatGPT and Gemini recommend, and which web pages they cite</a:t>
             </a:r>
@@ -3338,7 +3338,7 @@
                 <a:solidFill>
                   <a:srgbClr val="F6F3EC"/>
                 </a:solidFill>
-                <a:latin typeface="Instrument Sans"/>
+                <a:latin typeface="DM Sans"/>
               </a:rPr>
               <a:t>Rahmananda Ridho Gamawan, data analyst</a:t>
             </a:r>
@@ -3447,7 +3447,7 @@
                 <a:solidFill>
                   <a:srgbClr val="4A5568"/>
                 </a:solidFill>
-                <a:latin typeface="Instrument Sans"/>
+                <a:latin typeface="DM Sans"/>
               </a:rPr>
               <a:t>Part II: The answers</a:t>
             </a:r>
@@ -3463,7 +3463,7 @@
         <p:spPr>
           <a:xfrm>
             <a:off x="762000" y="1079500"/>
-            <a:ext cx="4064000" cy="3029712"/>
+            <a:ext cx="4064000" cy="3246120"/>
           </a:xfrm>
           <a:prstGeom prst="rect">
             <a:avLst/>
@@ -3482,11 +3482,11 @@
               </a:lnSpc>
             </a:pPr>
             <a:r>
-              <a:rPr sz="4200" b="0" i="0">
+              <a:rPr sz="3600" b="0" i="0">
                 <a:solidFill>
                   <a:srgbClr val="13294B"/>
                 </a:solidFill>
-                <a:latin typeface="Instrument Serif"/>
+                <a:latin typeface="DM Serif Display"/>
               </a:rPr>
               <a:t>BCA, Bank Jago and SeaBank are each named in more than half of all answers</a:t>
             </a:r>
@@ -3501,7 +3501,7 @@
         </p:nvSpPr>
         <p:spPr>
           <a:xfrm>
-            <a:off x="762000" y="4299712"/>
+            <a:off x="762000" y="4516120"/>
             <a:ext cx="3810000" cy="1190244"/>
           </a:xfrm>
           <a:prstGeom prst="rect">
@@ -3525,7 +3525,7 @@
                 <a:solidFill>
                   <a:srgbClr val="4A5568"/>
                 </a:solidFill>
-                <a:latin typeface="Instrument Sans"/>
+                <a:latin typeface="DM Sans"/>
               </a:rPr>
               <a:t>BCA and Bank Jago appear in 22 of 40 answers, SeaBank in 21 and BRI in 12.</a:t>
             </a:r>
@@ -3588,7 +3588,7 @@
                 <a:solidFill>
                   <a:srgbClr val="4A5568"/>
                 </a:solidFill>
-                <a:latin typeface="Instrument Sans"/>
+                <a:latin typeface="DM Sans"/>
               </a:rPr>
               <a:t>Source: data/processed/brand_engine.csv. Top 10 banks, n = 20 answers per engine</a:t>
             </a:r>
@@ -3627,7 +3627,7 @@
                 <a:solidFill>
                   <a:srgbClr val="4A5568"/>
                 </a:solidFill>
-                <a:latin typeface="Instrument Sans"/>
+                <a:latin typeface="DM Sans"/>
               </a:rPr>
               <a:t>11 / 33</a:t>
             </a:r>
@@ -3819,7 +3819,7 @@
                 <a:solidFill>
                   <a:srgbClr val="4B5563"/>
                 </a:solidFill>
-                <a:latin typeface="Instrument Sans"/>
+                <a:latin typeface="IBM Plex Sans"/>
               </a:rPr>
               <a:t>Which Indonesian banks ChatGPT and Gemini recommend, and which web pages they cite</a:t>
             </a:r>
@@ -3858,7 +3858,7 @@
                 <a:solidFill>
                   <a:srgbClr val="0E2A52"/>
                 </a:solidFill>
-                <a:latin typeface="Instrument Sans"/>
+                <a:latin typeface="IBM Plex Sans"/>
               </a:rPr>
               <a:t>Rahmananda Ridho Gamawan, data analyst. 40 answers, collected on 9 October 2026</a:t>
             </a:r>
@@ -3967,7 +3967,7 @@
                 <a:solidFill>
                   <a:srgbClr val="C9D4E5"/>
                 </a:solidFill>
-                <a:latin typeface="Instrument Sans"/>
+                <a:latin typeface="IBM Plex Sans"/>
               </a:rPr>
               <a:t>Part II: The answers</a:t>
             </a:r>
@@ -4045,7 +4045,7 @@
                 <a:solidFill>
                   <a:srgbClr val="4B5563"/>
                 </a:solidFill>
-                <a:latin typeface="Instrument Sans"/>
+                <a:latin typeface="IBM Plex Sans"/>
               </a:rPr>
               <a:t>BCA and Bank Jago appear in 22 of 40 answers, SeaBank in 21 and BRI in 12.</a:t>
             </a:r>
@@ -4108,7 +4108,7 @@
                 <a:solidFill>
                   <a:srgbClr val="4B5563"/>
                 </a:solidFill>
-                <a:latin typeface="Instrument Sans"/>
+                <a:latin typeface="IBM Plex Sans"/>
               </a:rPr>
               <a:t>Source: data/processed/brand_engine.csv. Top 10 banks, n = 20 answers per engine</a:t>
             </a:r>
@@ -4147,7 +4147,7 @@
                 <a:solidFill>
                   <a:srgbClr val="4B5563"/>
                 </a:solidFill>
-                <a:latin typeface="Instrument Sans"/>
+                <a:latin typeface="IBM Plex Sans"/>
               </a:rPr>
               <a:t>11 / 33</a:t>
             </a:r>
@@ -4280,7 +4280,7 @@
                 <a:solidFill>
                   <a:srgbClr val="AFC0D8"/>
                 </a:solidFill>
-                <a:latin typeface="Outfit"/>
+                <a:latin typeface="Plus Jakarta Sans"/>
               </a:rPr>
               <a:t>40 answers, collected on 9 October 2026</a:t>
             </a:r>
@@ -4319,7 +4319,7 @@
                 <a:solidFill>
                   <a:srgbClr val="F4F6FA"/>
                 </a:solidFill>
-                <a:latin typeface="Outfit"/>
+                <a:latin typeface="Plus Jakarta Sans"/>
               </a:rPr>
               <a:t>Favoured Banks</a:t>
             </a:r>
@@ -4402,7 +4402,7 @@
                 <a:solidFill>
                   <a:srgbClr val="AFC0D8"/>
                 </a:solidFill>
-                <a:latin typeface="Outfit"/>
+                <a:latin typeface="Plus Jakarta Sans"/>
               </a:rPr>
               <a:t>Which Indonesian banks ChatGPT and Gemini recommend, and which web pages they cite</a:t>
             </a:r>
@@ -4441,7 +4441,7 @@
                 <a:solidFill>
                   <a:srgbClr val="F4F6FA"/>
                 </a:solidFill>
-                <a:latin typeface="Outfit"/>
+                <a:latin typeface="Plus Jakarta Sans"/>
               </a:rPr>
               <a:t>Rahmananda Ridho Gamawan, data analyst</a:t>
             </a:r>
@@ -4506,7 +4506,7 @@
                 <a:solidFill>
                   <a:srgbClr val="AFC0D8"/>
                 </a:solidFill>
-                <a:latin typeface="Outfit"/>
+                <a:latin typeface="Plus Jakarta Sans"/>
               </a:rPr>
               <a:t>Part II: The answers</a:t>
             </a:r>
@@ -4545,7 +4545,7 @@
                 <a:solidFill>
                   <a:srgbClr val="F4F6FA"/>
                 </a:solidFill>
-                <a:latin typeface="Outfit"/>
+                <a:latin typeface="Plus Jakarta Sans"/>
               </a:rPr>
               <a:t>BCA, Bank Jago and SeaBank are each named in more than half of all answers</a:t>
             </a:r>
@@ -4584,7 +4584,7 @@
                 <a:solidFill>
                   <a:srgbClr val="AFC0D8"/>
                 </a:solidFill>
-                <a:latin typeface="Outfit"/>
+                <a:latin typeface="Plus Jakarta Sans"/>
               </a:rPr>
               <a:t>BCA and Bank Jago appear in 22 of 40 answers, SeaBank in 21 and BRI in 12.</a:t>
             </a:r>
@@ -4647,7 +4647,7 @@
                 <a:solidFill>
                   <a:srgbClr val="AFC0D8"/>
                 </a:solidFill>
-                <a:latin typeface="Outfit"/>
+                <a:latin typeface="Plus Jakarta Sans"/>
               </a:rPr>
               <a:t>Source: data/processed/brand_engine.csv. Top 10 banks, n = 20 answers per engine</a:t>
             </a:r>
@@ -4686,7 +4686,7 @@
                 <a:solidFill>
                   <a:srgbClr val="AFC0D8"/>
                 </a:solidFill>
-                <a:latin typeface="Outfit"/>
+                <a:latin typeface="Plus Jakarta Sans"/>
               </a:rPr>
               <a:t>11 / 33</a:t>
             </a:r>

</xml_diff>